<commit_message>
update paper for lecture 3
</commit_message>
<xml_diff>
--- a/papers/lektion-3.pptx
+++ b/papers/lektion-3.pptx
@@ -244,7 +244,7 @@
           <a:p>
             <a:fld id="{FC23D672-218E-44CF-A13C-71AB61B14F4F}" type="datetimeFigureOut">
               <a:rPr lang="de-CH" smtClean="0"/>
-              <a:t>03.02.2025</a:t>
+              <a:t>16.01.2026</a:t>
             </a:fld>
             <a:endParaRPr lang="de-CH"/>
           </a:p>
@@ -409,7 +409,7 @@
           <a:p>
             <a:fld id="{93FA598B-8DA1-4BBA-9EA9-DC1615E9868A}" type="datetimeFigureOut">
               <a:rPr lang="de-CH" smtClean="0"/>
-              <a:t>03.02.2025</a:t>
+              <a:t>16.01.2026</a:t>
             </a:fld>
             <a:endParaRPr lang="de-CH"/>
           </a:p>
@@ -1507,7 +1507,7 @@
           <a:p>
             <a:fld id="{6853F526-C1D0-4550-B781-F5C2F41E5AD9}" type="datetime1">
               <a:rPr lang="de-CH" smtClean="0"/>
-              <a:t>03.02.2025</a:t>
+              <a:t>16.01.2026</a:t>
             </a:fld>
             <a:endParaRPr lang="de-CH"/>
           </a:p>
@@ -1643,7 +1643,7 @@
           <a:p>
             <a:fld id="{A1523D7E-84BA-4532-8AC0-0461707F3C45}" type="datetime1">
               <a:rPr lang="de-CH" smtClean="0"/>
-              <a:t>03.02.2025</a:t>
+              <a:t>16.01.2026</a:t>
             </a:fld>
             <a:endParaRPr lang="de-CH"/>
           </a:p>
@@ -1801,7 +1801,7 @@
           <a:p>
             <a:fld id="{A1523D7E-84BA-4532-8AC0-0461707F3C45}" type="datetime1">
               <a:rPr lang="de-CH" smtClean="0"/>
-              <a:t>03.02.2025</a:t>
+              <a:t>16.01.2026</a:t>
             </a:fld>
             <a:endParaRPr lang="de-CH"/>
           </a:p>
@@ -2429,7 +2429,7 @@
           <a:p>
             <a:fld id="{107B2E98-33F3-4843-92CD-A9A795F13784}" type="datetime1">
               <a:rPr lang="de-CH" smtClean="0"/>
-              <a:t>03.02.2025</a:t>
+              <a:t>16.01.2026</a:t>
             </a:fld>
             <a:endParaRPr lang="de-CH"/>
           </a:p>
@@ -2558,7 +2558,7 @@
           <a:p>
             <a:fld id="{A1523D7E-84BA-4532-8AC0-0461707F3C45}" type="datetime1">
               <a:rPr lang="de-CH" smtClean="0"/>
-              <a:t>03.02.2025</a:t>
+              <a:t>16.01.2026</a:t>
             </a:fld>
             <a:endParaRPr lang="de-CH"/>
           </a:p>
@@ -3200,7 +3200,7 @@
           <a:p>
             <a:fld id="{6853F526-C1D0-4550-B781-F5C2F41E5AD9}" type="datetime1">
               <a:rPr lang="de-CH" smtClean="0"/>
-              <a:t>03.02.2025</a:t>
+              <a:t>16.01.2026</a:t>
             </a:fld>
             <a:endParaRPr lang="de-CH"/>
           </a:p>
@@ -3336,7 +3336,7 @@
           <a:p>
             <a:fld id="{A1523D7E-84BA-4532-8AC0-0461707F3C45}" type="datetime1">
               <a:rPr lang="de-CH" smtClean="0"/>
-              <a:t>03.02.2025</a:t>
+              <a:t>16.01.2026</a:t>
             </a:fld>
             <a:endParaRPr lang="de-CH"/>
           </a:p>
@@ -3579,7 +3579,7 @@
           <a:p>
             <a:fld id="{A1523D7E-84BA-4532-8AC0-0461707F3C45}" type="datetime1">
               <a:rPr lang="de-CH" smtClean="0"/>
-              <a:t>03.02.2025</a:t>
+              <a:t>16.01.2026</a:t>
             </a:fld>
             <a:endParaRPr lang="de-CH"/>
           </a:p>
@@ -3895,7 +3895,7 @@
           <a:p>
             <a:fld id="{A1523D7E-84BA-4532-8AC0-0461707F3C45}" type="datetime1">
               <a:rPr lang="de-CH" smtClean="0"/>
-              <a:t>03.02.2025</a:t>
+              <a:t>16.01.2026</a:t>
             </a:fld>
             <a:endParaRPr lang="de-CH"/>
           </a:p>
@@ -4259,7 +4259,7 @@
           <a:p>
             <a:fld id="{0F06BCF4-0E81-4303-B76F-6C3D6B7E70BE}" type="datetime1">
               <a:rPr lang="de-CH" smtClean="0"/>
-              <a:t>03.02.2025</a:t>
+              <a:t>16.01.2026</a:t>
             </a:fld>
             <a:endParaRPr lang="de-CH"/>
           </a:p>
@@ -4383,7 +4383,7 @@
           <a:p>
             <a:fld id="{A1523D7E-84BA-4532-8AC0-0461707F3C45}" type="datetime1">
               <a:rPr lang="de-CH" smtClean="0"/>
-              <a:t>03.02.2025</a:t>
+              <a:t>16.01.2026</a:t>
             </a:fld>
             <a:endParaRPr lang="de-CH"/>
           </a:p>
@@ -4629,7 +4629,7 @@
             <a:fld id="{A1523D7E-84BA-4532-8AC0-0461707F3C45}" type="datetime1">
               <a:rPr lang="de-CH" smtClean="0"/>
               <a:pPr/>
-              <a:t>03.02.2025</a:t>
+              <a:t>16.01.2026</a:t>
             </a:fld>
             <a:endParaRPr lang="de-CH" dirty="0"/>
           </a:p>
@@ -5193,7 +5193,7 @@
           <a:p>
             <a:r>
               <a:rPr lang="de-CH" dirty="0"/>
-              <a:t>03.02.2025</a:t>
+              <a:t>02.02.2026</a:t>
             </a:r>
           </a:p>
         </p:txBody>
@@ -6599,7 +6599,7 @@
         </p:blipFill>
         <p:spPr bwMode="auto">
           <a:xfrm>
-            <a:off x="5947064" y="1829677"/>
+            <a:off x="5753100" y="1854729"/>
             <a:ext cx="5715000" cy="1514475"/>
           </a:xfrm>
           <a:prstGeom prst="rect">
@@ -6745,14 +6745,14 @@
           <a:p>
             <a:r>
               <a:rPr lang="de-CH" dirty="0"/>
-              <a:t>Teste deine Implementation auf dem Smartphone: Laufe draussen umher (max. 5 min.) und zeichne deine Location auf.</a:t>
+              <a:t>Teste deine Implementation auf dem Smartphone: Laufe draussen umher (10 min.) und zeichne deine Location auf.</a:t>
             </a:r>
           </a:p>
           <a:p>
             <a:pPr lvl="1"/>
             <a:r>
               <a:rPr lang="de-CH" dirty="0"/>
-              <a:t>Public Hosting z.B. mit GitHub Pages</a:t>
+              <a:t>Public Hosting z.B. mit GitHub Pages nötig</a:t>
             </a:r>
           </a:p>
           <a:p>
@@ -6959,7 +6959,7 @@
                 <a:ea typeface="Open Sans Light" pitchFamily="2" charset="0"/>
                 <a:cs typeface="Open Sans Light" pitchFamily="2" charset="0"/>
               </a:rPr>
-              <a:t>Bonus Bonus 2: Speichere die Route im </a:t>
+              <a:t>Bonus Bonus 2: Speichere die Routen im </a:t>
             </a:r>
             <a:r>
               <a:rPr lang="de-CH" kern="1200" dirty="0" err="1">
@@ -7913,6 +7913,15 @@
 </file>
 
 <file path=customXml/item1.xml><?xml version="1.0" encoding="utf-8"?>
+<?mso-contentType ?>
+<FormTemplates xmlns="http://schemas.microsoft.com/sharepoint/v3/contenttype/forms">
+  <Display>DocumentLibraryForm</Display>
+  <Edit>DocumentLibraryForm</Edit>
+  <New>DocumentLibraryForm</New>
+</FormTemplates>
+</file>
+
+<file path=customXml/item2.xml><?xml version="1.0" encoding="utf-8"?>
 <p:properties xmlns:p="http://schemas.microsoft.com/office/2006/metadata/properties" xmlns:xsi="http://www.w3.org/2001/XMLSchema-instance" xmlns:pc="http://schemas.microsoft.com/office/infopath/2007/PartnerControls">
   <documentManagement>
     <MediaLengthInSeconds xmlns="1dbf6c8a-8f63-44bb-83c7-9ba9b5d4efe9" xsi:nil="true"/>
@@ -7922,15 +7931,6 @@
     <TaxCatchAll xmlns="06172d57-5d51-4d29-806c-4b74cd929571" xsi:nil="true"/>
   </documentManagement>
 </p:properties>
-</file>
-
-<file path=customXml/item2.xml><?xml version="1.0" encoding="utf-8"?>
-<?mso-contentType ?>
-<FormTemplates xmlns="http://schemas.microsoft.com/sharepoint/v3/contenttype/forms">
-  <Display>DocumentLibraryForm</Display>
-  <Edit>DocumentLibraryForm</Edit>
-  <New>DocumentLibraryForm</New>
-</FormTemplates>
 </file>
 
 <file path=customXml/item3.xml><?xml version="1.0" encoding="utf-8"?>
@@ -8163,20 +8163,20 @@
 </file>
 
 <file path=customXml/itemProps1.xml><?xml version="1.0" encoding="utf-8"?>
+<ds:datastoreItem xmlns:ds="http://schemas.openxmlformats.org/officeDocument/2006/customXml" ds:itemID="{1AE3F8FF-813C-4132-BE80-C573B634B911}">
+  <ds:schemaRefs>
+    <ds:schemaRef ds:uri="http://schemas.microsoft.com/sharepoint/v3/contenttype/forms"/>
+  </ds:schemaRefs>
+</ds:datastoreItem>
+</file>
+
+<file path=customXml/itemProps2.xml><?xml version="1.0" encoding="utf-8"?>
 <ds:datastoreItem xmlns:ds="http://schemas.openxmlformats.org/officeDocument/2006/customXml" ds:itemID="{C75C5BEF-A826-4D32-BB75-8169F3E7AF17}">
   <ds:schemaRefs>
     <ds:schemaRef ds:uri="http://schemas.microsoft.com/office/2006/metadata/properties"/>
     <ds:schemaRef ds:uri="http://schemas.microsoft.com/office/infopath/2007/PartnerControls"/>
     <ds:schemaRef ds:uri="1dbf6c8a-8f63-44bb-83c7-9ba9b5d4efe9"/>
     <ds:schemaRef ds:uri="06172d57-5d51-4d29-806c-4b74cd929571"/>
-  </ds:schemaRefs>
-</ds:datastoreItem>
-</file>
-
-<file path=customXml/itemProps2.xml><?xml version="1.0" encoding="utf-8"?>
-<ds:datastoreItem xmlns:ds="http://schemas.openxmlformats.org/officeDocument/2006/customXml" ds:itemID="{1AE3F8FF-813C-4132-BE80-C573B634B911}">
-  <ds:schemaRefs>
-    <ds:schemaRef ds:uri="http://schemas.microsoft.com/sharepoint/v3/contenttype/forms"/>
   </ds:schemaRefs>
 </ds:datastoreItem>
 </file>

</xml_diff>

<commit_message>
update papers for lecture 3
</commit_message>
<xml_diff>
--- a/papers/lektion-3.pptx
+++ b/papers/lektion-3.pptx
@@ -244,7 +244,7 @@
           <a:p>
             <a:fld id="{FC23D672-218E-44CF-A13C-71AB61B14F4F}" type="datetimeFigureOut">
               <a:rPr lang="de-CH" smtClean="0"/>
-              <a:t>16.01.2026</a:t>
+              <a:t>01.02.2026</a:t>
             </a:fld>
             <a:endParaRPr lang="de-CH"/>
           </a:p>
@@ -409,7 +409,7 @@
           <a:p>
             <a:fld id="{93FA598B-8DA1-4BBA-9EA9-DC1615E9868A}" type="datetimeFigureOut">
               <a:rPr lang="de-CH" smtClean="0"/>
-              <a:t>16.01.2026</a:t>
+              <a:t>01.02.2026</a:t>
             </a:fld>
             <a:endParaRPr lang="de-CH"/>
           </a:p>
@@ -1507,7 +1507,7 @@
           <a:p>
             <a:fld id="{6853F526-C1D0-4550-B781-F5C2F41E5AD9}" type="datetime1">
               <a:rPr lang="de-CH" smtClean="0"/>
-              <a:t>16.01.2026</a:t>
+              <a:t>01.02.2026</a:t>
             </a:fld>
             <a:endParaRPr lang="de-CH"/>
           </a:p>
@@ -1643,7 +1643,7 @@
           <a:p>
             <a:fld id="{A1523D7E-84BA-4532-8AC0-0461707F3C45}" type="datetime1">
               <a:rPr lang="de-CH" smtClean="0"/>
-              <a:t>16.01.2026</a:t>
+              <a:t>01.02.2026</a:t>
             </a:fld>
             <a:endParaRPr lang="de-CH"/>
           </a:p>
@@ -1801,7 +1801,7 @@
           <a:p>
             <a:fld id="{A1523D7E-84BA-4532-8AC0-0461707F3C45}" type="datetime1">
               <a:rPr lang="de-CH" smtClean="0"/>
-              <a:t>16.01.2026</a:t>
+              <a:t>01.02.2026</a:t>
             </a:fld>
             <a:endParaRPr lang="de-CH"/>
           </a:p>
@@ -2429,7 +2429,7 @@
           <a:p>
             <a:fld id="{107B2E98-33F3-4843-92CD-A9A795F13784}" type="datetime1">
               <a:rPr lang="de-CH" smtClean="0"/>
-              <a:t>16.01.2026</a:t>
+              <a:t>01.02.2026</a:t>
             </a:fld>
             <a:endParaRPr lang="de-CH"/>
           </a:p>
@@ -2558,7 +2558,7 @@
           <a:p>
             <a:fld id="{A1523D7E-84BA-4532-8AC0-0461707F3C45}" type="datetime1">
               <a:rPr lang="de-CH" smtClean="0"/>
-              <a:t>16.01.2026</a:t>
+              <a:t>01.02.2026</a:t>
             </a:fld>
             <a:endParaRPr lang="de-CH"/>
           </a:p>
@@ -3200,7 +3200,7 @@
           <a:p>
             <a:fld id="{6853F526-C1D0-4550-B781-F5C2F41E5AD9}" type="datetime1">
               <a:rPr lang="de-CH" smtClean="0"/>
-              <a:t>16.01.2026</a:t>
+              <a:t>01.02.2026</a:t>
             </a:fld>
             <a:endParaRPr lang="de-CH"/>
           </a:p>
@@ -3336,7 +3336,7 @@
           <a:p>
             <a:fld id="{A1523D7E-84BA-4532-8AC0-0461707F3C45}" type="datetime1">
               <a:rPr lang="de-CH" smtClean="0"/>
-              <a:t>16.01.2026</a:t>
+              <a:t>01.02.2026</a:t>
             </a:fld>
             <a:endParaRPr lang="de-CH"/>
           </a:p>
@@ -3579,7 +3579,7 @@
           <a:p>
             <a:fld id="{A1523D7E-84BA-4532-8AC0-0461707F3C45}" type="datetime1">
               <a:rPr lang="de-CH" smtClean="0"/>
-              <a:t>16.01.2026</a:t>
+              <a:t>01.02.2026</a:t>
             </a:fld>
             <a:endParaRPr lang="de-CH"/>
           </a:p>
@@ -3895,7 +3895,7 @@
           <a:p>
             <a:fld id="{A1523D7E-84BA-4532-8AC0-0461707F3C45}" type="datetime1">
               <a:rPr lang="de-CH" smtClean="0"/>
-              <a:t>16.01.2026</a:t>
+              <a:t>01.02.2026</a:t>
             </a:fld>
             <a:endParaRPr lang="de-CH"/>
           </a:p>
@@ -4259,7 +4259,7 @@
           <a:p>
             <a:fld id="{0F06BCF4-0E81-4303-B76F-6C3D6B7E70BE}" type="datetime1">
               <a:rPr lang="de-CH" smtClean="0"/>
-              <a:t>16.01.2026</a:t>
+              <a:t>01.02.2026</a:t>
             </a:fld>
             <a:endParaRPr lang="de-CH"/>
           </a:p>
@@ -4383,7 +4383,7 @@
           <a:p>
             <a:fld id="{A1523D7E-84BA-4532-8AC0-0461707F3C45}" type="datetime1">
               <a:rPr lang="de-CH" smtClean="0"/>
-              <a:t>16.01.2026</a:t>
+              <a:t>01.02.2026</a:t>
             </a:fld>
             <a:endParaRPr lang="de-CH"/>
           </a:p>
@@ -4629,7 +4629,7 @@
             <a:fld id="{A1523D7E-84BA-4532-8AC0-0461707F3C45}" type="datetime1">
               <a:rPr lang="de-CH" smtClean="0"/>
               <a:pPr/>
-              <a:t>16.01.2026</a:t>
+              <a:t>01.02.2026</a:t>
             </a:fld>
             <a:endParaRPr lang="de-CH" dirty="0"/>
           </a:p>
@@ -6561,12 +6561,15 @@
               <a:rPr lang="de-CH" dirty="0">
                 <a:hlinkClick r:id="rId3"/>
               </a:rPr>
-              <a:t>https://api3.geo.admin.ch/api/examples.html#other-js-web-mapping-apis-integration</a:t>
+              <a:t>https://docs.geo.admin.ch/visualize-data/xyz.html</a:t>
             </a:r>
             <a:endParaRPr lang="de-CH" dirty="0"/>
           </a:p>
           <a:p>
-            <a:endParaRPr lang="LID4096" dirty="0"/>
+            <a:pPr marL="0" indent="0">
+              <a:buNone/>
+            </a:pPr>
+            <a:endParaRPr lang="de-CH" dirty="0"/>
           </a:p>
         </p:txBody>
       </p:sp>
@@ -6752,7 +6755,7 @@
             <a:pPr lvl="1"/>
             <a:r>
               <a:rPr lang="de-CH" dirty="0"/>
-              <a:t>Public Hosting z.B. mit GitHub Pages nötig</a:t>
+              <a:t>Public Hosting z.B. mit GitHub Pages nötig (Repo publishen)</a:t>
             </a:r>
           </a:p>
           <a:p>
@@ -7913,27 +7916,6 @@
 </file>
 
 <file path=customXml/item1.xml><?xml version="1.0" encoding="utf-8"?>
-<?mso-contentType ?>
-<FormTemplates xmlns="http://schemas.microsoft.com/sharepoint/v3/contenttype/forms">
-  <Display>DocumentLibraryForm</Display>
-  <Edit>DocumentLibraryForm</Edit>
-  <New>DocumentLibraryForm</New>
-</FormTemplates>
-</file>
-
-<file path=customXml/item2.xml><?xml version="1.0" encoding="utf-8"?>
-<p:properties xmlns:p="http://schemas.microsoft.com/office/2006/metadata/properties" xmlns:xsi="http://www.w3.org/2001/XMLSchema-instance" xmlns:pc="http://schemas.microsoft.com/office/infopath/2007/PartnerControls">
-  <documentManagement>
-    <MediaLengthInSeconds xmlns="1dbf6c8a-8f63-44bb-83c7-9ba9b5d4efe9" xsi:nil="true"/>
-    <lcf76f155ced4ddcb4097134ff3c332f xmlns="1dbf6c8a-8f63-44bb-83c7-9ba9b5d4efe9">
-      <Terms xmlns="http://schemas.microsoft.com/office/infopath/2007/PartnerControls"/>
-    </lcf76f155ced4ddcb4097134ff3c332f>
-    <TaxCatchAll xmlns="06172d57-5d51-4d29-806c-4b74cd929571" xsi:nil="true"/>
-  </documentManagement>
-</p:properties>
-</file>
-
-<file path=customXml/item3.xml><?xml version="1.0" encoding="utf-8"?>
 <ct:contentTypeSchema xmlns:ct="http://schemas.microsoft.com/office/2006/metadata/contentType" xmlns:ma="http://schemas.microsoft.com/office/2006/metadata/properties/metaAttributes" ct:_="" ma:_="" ma:contentTypeName="Document" ma:contentTypeID="0x0101001CD6A808F5B18B4EAF5BA513ACEC1F15" ma:contentTypeVersion="14" ma:contentTypeDescription="Crée un document." ma:contentTypeScope="" ma:versionID="90cadc050c97ef17732eccf05f282cbe">
   <xsd:schema xmlns:xsd="http://www.w3.org/2001/XMLSchema" xmlns:xs="http://www.w3.org/2001/XMLSchema" xmlns:p="http://schemas.microsoft.com/office/2006/metadata/properties" xmlns:ns2="1dbf6c8a-8f63-44bb-83c7-9ba9b5d4efe9" xmlns:ns3="06172d57-5d51-4d29-806c-4b74cd929571" targetNamespace="http://schemas.microsoft.com/office/2006/metadata/properties" ma:root="true" ma:fieldsID="4f5492ae7e1fa14b86c16250e6d1a161" ns2:_="" ns3:_="">
     <xsd:import namespace="1dbf6c8a-8f63-44bb-83c7-9ba9b5d4efe9"/>
@@ -8162,10 +8144,42 @@
 </ct:contentTypeSchema>
 </file>
 
+<file path=customXml/item2.xml><?xml version="1.0" encoding="utf-8"?>
+<p:properties xmlns:p="http://schemas.microsoft.com/office/2006/metadata/properties" xmlns:xsi="http://www.w3.org/2001/XMLSchema-instance" xmlns:pc="http://schemas.microsoft.com/office/infopath/2007/PartnerControls">
+  <documentManagement>
+    <MediaLengthInSeconds xmlns="1dbf6c8a-8f63-44bb-83c7-9ba9b5d4efe9" xsi:nil="true"/>
+    <lcf76f155ced4ddcb4097134ff3c332f xmlns="1dbf6c8a-8f63-44bb-83c7-9ba9b5d4efe9">
+      <Terms xmlns="http://schemas.microsoft.com/office/infopath/2007/PartnerControls"/>
+    </lcf76f155ced4ddcb4097134ff3c332f>
+    <TaxCatchAll xmlns="06172d57-5d51-4d29-806c-4b74cd929571" xsi:nil="true"/>
+  </documentManagement>
+</p:properties>
+</file>
+
+<file path=customXml/item3.xml><?xml version="1.0" encoding="utf-8"?>
+<?mso-contentType ?>
+<FormTemplates xmlns="http://schemas.microsoft.com/sharepoint/v3/contenttype/forms">
+  <Display>DocumentLibraryForm</Display>
+  <Edit>DocumentLibraryForm</Edit>
+  <New>DocumentLibraryForm</New>
+</FormTemplates>
+</file>
+
 <file path=customXml/itemProps1.xml><?xml version="1.0" encoding="utf-8"?>
-<ds:datastoreItem xmlns:ds="http://schemas.openxmlformats.org/officeDocument/2006/customXml" ds:itemID="{1AE3F8FF-813C-4132-BE80-C573B634B911}">
+<ds:datastoreItem xmlns:ds="http://schemas.openxmlformats.org/officeDocument/2006/customXml" ds:itemID="{6DE9BA2F-C062-493E-910C-72A955AF13B0}">
   <ds:schemaRefs>
-    <ds:schemaRef ds:uri="http://schemas.microsoft.com/sharepoint/v3/contenttype/forms"/>
+    <ds:schemaRef ds:uri="http://schemas.microsoft.com/office/2006/metadata/contentType"/>
+    <ds:schemaRef ds:uri="http://schemas.microsoft.com/office/2006/metadata/properties/metaAttributes"/>
+    <ds:schemaRef ds:uri="http://www.w3.org/2001/XMLSchema"/>
+    <ds:schemaRef ds:uri="http://schemas.microsoft.com/office/2006/metadata/properties"/>
+    <ds:schemaRef ds:uri="1dbf6c8a-8f63-44bb-83c7-9ba9b5d4efe9"/>
+    <ds:schemaRef ds:uri="06172d57-5d51-4d29-806c-4b74cd929571"/>
+    <ds:schemaRef ds:uri="http://schemas.microsoft.com/office/2006/documentManagement/types"/>
+    <ds:schemaRef ds:uri="http://schemas.microsoft.com/office/infopath/2007/PartnerControls"/>
+    <ds:schemaRef ds:uri="http://schemas.openxmlformats.org/package/2006/metadata/core-properties"/>
+    <ds:schemaRef ds:uri="http://purl.org/dc/elements/1.1/"/>
+    <ds:schemaRef ds:uri="http://purl.org/dc/terms/"/>
+    <ds:schemaRef ds:uri="http://schemas.microsoft.com/internal/obd"/>
   </ds:schemaRefs>
 </ds:datastoreItem>
 </file>
@@ -8182,20 +8196,9 @@
 </file>
 
 <file path=customXml/itemProps3.xml><?xml version="1.0" encoding="utf-8"?>
-<ds:datastoreItem xmlns:ds="http://schemas.openxmlformats.org/officeDocument/2006/customXml" ds:itemID="{6DE9BA2F-C062-493E-910C-72A955AF13B0}">
+<ds:datastoreItem xmlns:ds="http://schemas.openxmlformats.org/officeDocument/2006/customXml" ds:itemID="{1AE3F8FF-813C-4132-BE80-C573B634B911}">
   <ds:schemaRefs>
-    <ds:schemaRef ds:uri="http://schemas.microsoft.com/office/2006/metadata/contentType"/>
-    <ds:schemaRef ds:uri="http://schemas.microsoft.com/office/2006/metadata/properties/metaAttributes"/>
-    <ds:schemaRef ds:uri="http://www.w3.org/2001/XMLSchema"/>
-    <ds:schemaRef ds:uri="http://schemas.microsoft.com/office/2006/metadata/properties"/>
-    <ds:schemaRef ds:uri="1dbf6c8a-8f63-44bb-83c7-9ba9b5d4efe9"/>
-    <ds:schemaRef ds:uri="06172d57-5d51-4d29-806c-4b74cd929571"/>
-    <ds:schemaRef ds:uri="http://schemas.microsoft.com/office/2006/documentManagement/types"/>
-    <ds:schemaRef ds:uri="http://schemas.microsoft.com/office/infopath/2007/PartnerControls"/>
-    <ds:schemaRef ds:uri="http://schemas.openxmlformats.org/package/2006/metadata/core-properties"/>
-    <ds:schemaRef ds:uri="http://purl.org/dc/elements/1.1/"/>
-    <ds:schemaRef ds:uri="http://purl.org/dc/terms/"/>
-    <ds:schemaRef ds:uri="http://schemas.microsoft.com/internal/obd"/>
+    <ds:schemaRef ds:uri="http://schemas.microsoft.com/sharepoint/v3/contenttype/forms"/>
   </ds:schemaRefs>
 </ds:datastoreItem>
 </file>
</xml_diff>